<commit_message>
Rewrite PwC deck copy for a more natural editorial voice
Reworked the callout-box and title copy across all 17 slides: removed the
repeated "X is not the problem — Y is" antithesis pattern from titles, broke
up the "Bold label: elaboration" formula that recurred on nearly every
colored box, varied sentence length and rhythm, and cut the em-dash density
in prose (labels and table cells keep their dashes where structurally
natural). No facts, figures, or numbers changed. Re-rendered and re-verified
against the format spec: 2 exec + 10 body + 4 appendix, 10pt font floor
(zero violations), Georgia/Arial only.

Co-Authored-By: Claude Sonnet 5 <noreply@anthropic.com>
Claude-Session: https://claude.ai/code/session_01LDRrcuagWm13SZpGnU8SQC
</commit_message>
<xml_diff>
--- a/cases/2026-08-pwc-challenge-8-styleverse/deck/PwC_Challenge8_StyleVerse_RanjanaMainani.pptx
+++ b/cases/2026-08-pwc-challenge-8-styleverse/deck/PwC_Challenge8_StyleVerse_RanjanaMainani.pptx
@@ -3514,7 +3514,7 @@
                 </a:solidFill>
                 <a:latin typeface="Arial"/>
               </a:rPr>
-              <a:t>An enterprise AI operating-model blueprint for StyleVerse Global —</a:t>
+              <a:t>An enterprise AI operating-model blueprint for StyleVerse Global. It automates</a:t>
             </a:r>
           </a:p>
           <a:p>
@@ -3533,7 +3533,7 @@
                 </a:solidFill>
                 <a:latin typeface="Arial"/>
               </a:rPr>
-              <a:t>automating 40% of routine work while protecting all 28,000 roles.</a:t>
+              <a:t>40% of routine work and protects all 28,000 roles while doing it.</a:t>
             </a:r>
           </a:p>
         </p:txBody>
@@ -3866,7 +3866,7 @@
                 </a:solidFill>
                 <a:latin typeface="Georgia"/>
               </a:rPr>
-              <a:t>Recommendation: a federated hub-and-spoke CoE — centralised standards, embedded delivery</a:t>
+              <a:t>Our recommendation: a federated hub-and-spoke CoE, centralised on standards, embedded on delivery</a:t>
             </a:r>
           </a:p>
         </p:txBody>
@@ -5079,22 +5079,31 @@
               </a:spcAft>
             </a:pPr>
             <a:r>
-              <a:rPr sz="1150" b="1" i="0">
-                <a:solidFill>
-                  <a:srgbClr val="FFB600"/>
+              <a:rPr sz="1150" b="0" i="0">
+                <a:solidFill>
+                  <a:srgbClr val="FFFFFF"/>
                 </a:solidFill>
                 <a:latin typeface="Arial"/>
               </a:rPr>
-              <a:t>The deciding argument:  </a:t>
-            </a:r>
-            <a:r>
-              <a:rPr sz="1150" b="0" i="0">
-                <a:solidFill>
-                  <a:srgbClr val="FFFFFF"/>
+              <a:t>Here's what settles it. StyleVerse's current mess exists because functions each introduced </a:t>
+            </a:r>
+            <a:r>
+              <a:rPr sz="1150" b="0" i="1">
+                <a:solidFill>
+                  <a:srgbClr val="FFB600"/>
                 </a:solidFill>
                 <a:latin typeface="Arial"/>
               </a:rPr>
-              <a:t>StyleVerse's current problem was caused by functions independently introducing “their own systems, processes and ways of working.” A fully embedded AI model would repeat that mistake with higher stakes — five brands each training their own models on their own data, with no shared governance and no shared learning.</a:t>
+              <a:t>“their own systems, processes and ways of working,”</a:t>
+            </a:r>
+            <a:r>
+              <a:rPr sz="1150" b="0" i="0">
+                <a:solidFill>
+                  <a:srgbClr val="FFFFFF"/>
+                </a:solidFill>
+                <a:latin typeface="Arial"/>
+              </a:rPr>
+              <a:t> in the case's own words. Go fully embedded on AI and you'd repeat that mistake, only bigger: five brands training five sets of models on five sets of data, no shared governance, nobody learning from anybody else's mistakes.</a:t>
             </a:r>
           </a:p>
         </p:txBody>
@@ -6788,7 +6797,7 @@
                 </a:solidFill>
                 <a:latin typeface="Arial"/>
               </a:rPr>
-              <a:t>Retail tenure is 1.7 years at 42% attrition — institutional knowledge is already leaking faster than it is being recorded.</a:t>
+              <a:t>Average tenure in Retail is 1.7 years against 42% attrition. Institutional knowledge is already leaking out faster than anyone's writing it down.</a:t>
             </a:r>
           </a:p>
           <a:p>
@@ -6807,7 +6816,7 @@
                 </a:solidFill>
                 <a:latin typeface="Arial"/>
               </a:rPr>
-              <a:t>We capture tacit know-how from the high-tenure functions (Corporate 5.1 yrs, Design 4.6 yrs) into structured knowledge bases </a:t>
+              <a:t>So </a:t>
             </a:r>
             <a:r>
               <a:rPr sz="1100" b="1" i="0">
@@ -6816,7 +6825,7 @@
                 </a:solidFill>
                 <a:latin typeface="Arial"/>
               </a:rPr>
-              <a:t>in Phase 0</a:t>
+              <a:t>Phase 0</a:t>
             </a:r>
             <a:r>
               <a:rPr sz="1100" b="0" i="0">
@@ -6825,7 +6834,7 @@
                 </a:solidFill>
                 <a:latin typeface="Arial"/>
               </a:rPr>
-              <a:t> — before automation changes the roles that hold it.</a:t>
+              <a:t> starts by pulling tacit know-how out of the longest-tenured functions — Corporate at 5.1 years, Design at 4.6 — into structured knowledge bases, before automation touches the roles that hold it.</a:t>
             </a:r>
           </a:p>
         </p:txBody>
@@ -6911,7 +6920,7 @@
                 </a:solidFill>
                 <a:latin typeface="Arial"/>
               </a:rPr>
-              <a:t>The Zero-Layoff mechanism:  </a:t>
+              <a:t>In practice, Zero-Layoff means three things: </a:t>
             </a:r>
             <a:r>
               <a:rPr sz="1150" b="0" i="0">
@@ -6920,7 +6929,7 @@
                 </a:solidFill>
                 <a:latin typeface="Arial"/>
               </a:rPr>
-              <a:t>a written redeployment guarantee, an internal talent marketplace matching released capacity to open roles on skills rather than titles, and a 90-day paid transition window with the learning journey completed before the role changes.</a:t>
+              <a:t>a written redeployment guarantee, an internal talent marketplace that matches people to open roles by skill rather than job title, and a 90-day paid transition window where the learning journey finishes before the role actually changes.</a:t>
             </a:r>
           </a:p>
         </p:txBody>
@@ -8810,22 +8819,22 @@
               </a:spcAft>
             </a:pPr>
             <a:r>
-              <a:rPr sz="1150" b="1" i="0">
-                <a:solidFill>
-                  <a:srgbClr val="FFB600"/>
+              <a:rPr sz="1150" b="0" i="0">
+                <a:solidFill>
+                  <a:srgbClr val="FFFFFF"/>
                 </a:solidFill>
                 <a:latin typeface="Arial"/>
               </a:rPr>
-              <a:t>Why brand-differentiated governance is the right call:  </a:t>
-            </a:r>
-            <a:r>
-              <a:rPr sz="1150" b="0" i="0">
-                <a:solidFill>
-                  <a:srgbClr val="FFFFFF"/>
+              <a:t>Maison Luxe has the best NPS in the portfolio (62) and the lowest return rate (8%), and both numbers exist because customers believe a person made the product. </a:t>
+            </a:r>
+            <a:r>
+              <a:rPr sz="1150" b="1" i="0">
+                <a:solidFill>
+                  <a:srgbClr val="FFB600"/>
                 </a:solidFill>
                 <a:latin typeface="Arial"/>
               </a:rPr>
-              <a:t>Maison Luxe earns the highest NPS (62) and the lowest return rate (8%) precisely because customers believe a person made it. Applying SpeedStyle's AI posture there would automate away the thing being sold.</a:t>
+              <a:t>Give it SpeedStyle's AI posture and you'd be automating away the exact thing people are paying for.</a:t>
             </a:r>
           </a:p>
         </p:txBody>
@@ -9107,7 +9116,7 @@
                 </a:solidFill>
                 <a:latin typeface="Georgia"/>
               </a:rPr>
-              <a:t>Fear is measurable, so it is manageable — we treat it as the primary delivery risk</a:t>
+              <a:t>Fear turns out to be measurable. That's why we treat it as the top delivery risk.</a:t>
             </a:r>
           </a:p>
         </p:txBody>
@@ -10119,22 +10128,13 @@
               </a:spcAft>
             </a:pPr>
             <a:r>
-              <a:rPr sz="1100" b="1" i="0">
+              <a:rPr sz="1100" b="0" i="0">
                 <a:solidFill>
                   <a:srgbClr val="2D2D2D"/>
                 </a:solidFill>
                 <a:latin typeface="Arial"/>
               </a:rPr>
-              <a:t>22% on people is deliberate. </a:t>
-            </a:r>
-            <a:r>
-              <a:rPr sz="1100" b="0" i="0">
-                <a:solidFill>
-                  <a:srgbClr val="2D2D2D"/>
-                </a:solidFill>
-                <a:latin typeface="Arial"/>
-              </a:rPr>
-              <a:t>Most transformations underfund reskilling and then discover the technology landed but the behaviour did not. Zero-Layoff is only credible if the redeployment budget is real.</a:t>
+              <a:t>The 22% going to people isn't a rounding error. Most transformations shortchange reskilling, then wonder why the technology worked but nobody's behaviour changed. Zero-Layoff only means something if the redeployment budget is real money.</a:t>
             </a:r>
           </a:p>
         </p:txBody>
@@ -10314,7 +10314,7 @@
                 </a:solidFill>
                 <a:latin typeface="Arial"/>
               </a:rPr>
-              <a:t>against ₹200 Cr one-time — payback under 12 months, and EBITDA margin from 9.5% to 13.1%.</a:t>
+              <a:t>against a ₹200 Cr one-time spend. Payback lands under 12 months; EBITDA margin moves from 9.5% to 13.1%.</a:t>
             </a:r>
           </a:p>
         </p:txBody>
@@ -15186,22 +15186,13 @@
               </a:spcAft>
             </a:pPr>
             <a:r>
-              <a:rPr sz="1050" b="1" i="0">
+              <a:rPr sz="1050" b="0" i="0">
                 <a:solidFill>
                   <a:srgbClr val="2D2D2D"/>
                 </a:solidFill>
                 <a:latin typeface="Arial"/>
               </a:rPr>
-              <a:t>Resulting EBITDA. </a:t>
-            </a:r>
-            <a:r>
-              <a:rPr sz="1050" b="0" i="0">
-                <a:solidFill>
-                  <a:srgbClr val="2D2D2D"/>
-                </a:solidFill>
-                <a:latin typeface="Arial"/>
-              </a:rPr>
-              <a:t>FY24 EBITDA = ₹5,600 Cr × 9.5% = ₹532 Cr. Adding ₹311 Cr gives ₹843 Cr. On FY26 revenue of ₹6,440 Cr (15% growth) that is a 13.1% margin.</a:t>
+              <a:t>FY24 EBITDA works out to ₹5,600 Cr × 9.5% = ₹532 Cr. Add the ₹311 Cr and you get ₹843 Cr. Against FY26 revenue of ₹6,440 Cr (15% growth), that's a 13.1% margin.</a:t>
             </a:r>
           </a:p>
           <a:p>
@@ -15220,7 +15211,7 @@
                 </a:solidFill>
                 <a:latin typeface="Arial"/>
               </a:rPr>
-              <a:t>Stated limitations. </a:t>
+              <a:t>One limitation worth stating plainly: </a:t>
             </a:r>
             <a:r>
               <a:rPr sz="1050" b="0" i="0">
@@ -15229,7 +15220,7 @@
                 </a:solidFill>
                 <a:latin typeface="Arial"/>
               </a:rPr>
-              <a:t>These are directional planning estimates built only from the case exhibits, not audited figures. Under Zero-Layoff, no labour-cost saving is claimed anywhere in this bridge — the 6,056 FTE-equivalents released are redeployed, and their value appears only through the business outcomes above.</a:t>
+              <a:t>these are directional planning estimates built only from the case exhibits, not audited figures. And under Zero-Layoff, no labour-cost saving is claimed anywhere in this bridge — the 6,056 FTE-equivalents released are redeployed, so their value shows up only through the business outcomes above.</a:t>
             </a:r>
           </a:p>
         </p:txBody>
@@ -16570,7 +16561,7 @@
                 </a:solidFill>
                 <a:latin typeface="Georgia"/>
               </a:rPr>
-              <a:t>AI should touch 82% of StyleVerse's work — and replace none of its 28,000 people</a:t>
+              <a:t>82% of StyleVerse's work should involve AI. None of the 28,000 people should lose a job over it.</a:t>
             </a:r>
           </a:p>
         </p:txBody>
@@ -16656,7 +16647,7 @@
                 </a:solidFill>
                 <a:latin typeface="Arial"/>
               </a:rPr>
-              <a:t>StyleVerse does not have a growth problem — it has a conversion problem. </a:t>
+              <a:t>Revenue keeps growing at StyleVerse; profit hasn't kept pace. </a:t>
             </a:r>
             <a:r>
               <a:rPr sz="1250" b="0" i="0">
@@ -16665,7 +16656,7 @@
                 </a:solidFill>
                 <a:latin typeface="Arial"/>
               </a:rPr>
-              <a:t>Insight becomes action too slowly because work, not talent, is mis-allocated. We re-architect every role into three tiers, automate 40% of routine work, and redeploy the released capacity into customer-facing work.</a:t>
+              <a:t>The gap comes from how slowly insight turns into action, because work — not talent — is misallocated across the business. We re-architect every role into three tiers, automate 40% of routine work, and move the capacity that frees up onto the customer-facing jobs that actually drive the 15% growth target.</a:t>
             </a:r>
           </a:p>
         </p:txBody>
@@ -16839,7 +16830,7 @@
                 </a:solidFill>
                 <a:latin typeface="Arial"/>
               </a:rPr>
-              <a:t>of all work is routine —</a:t>
+              <a:t>of all work is routine once</a:t>
             </a:r>
           </a:p>
           <a:p>
@@ -16858,7 +16849,7 @@
                 </a:solidFill>
                 <a:latin typeface="Arial"/>
               </a:rPr>
-              <a:t>not the 48% Exhibit 4</a:t>
+              <a:t>weighted by headcount —</a:t>
             </a:r>
           </a:p>
           <a:p>
@@ -16877,7 +16868,7 @@
                 </a:solidFill>
                 <a:latin typeface="Arial"/>
               </a:rPr>
-              <a:t>averages to (weighted</a:t>
+              <a:t>Exhibit 4's simple average</a:t>
             </a:r>
           </a:p>
           <a:p>
@@ -16896,7 +16887,7 @@
                 </a:solidFill>
                 <a:latin typeface="Arial"/>
               </a:rPr>
-              <a:t>by headcount)</a:t>
+              <a:t>says 48%</a:t>
             </a:r>
           </a:p>
         </p:txBody>
@@ -17070,7 +17061,7 @@
                 </a:solidFill>
                 <a:latin typeface="Arial"/>
               </a:rPr>
-              <a:t>FTE-equivalents of</a:t>
+              <a:t>FTE-equivalents released.</a:t>
             </a:r>
           </a:p>
           <a:p>
@@ -17089,7 +17080,7 @@
                 </a:solidFill>
                 <a:latin typeface="Arial"/>
               </a:rPr>
-              <a:t>capacity released —</a:t>
+              <a:t>Zero-Layoff means</a:t>
             </a:r>
           </a:p>
           <a:p>
@@ -17108,26 +17099,7 @@
                 </a:solidFill>
                 <a:latin typeface="Arial"/>
               </a:rPr>
-              <a:t>converted, not cut,</a:t>
-            </a:r>
-          </a:p>
-          <a:p>
-            <a:pPr algn="l">
-              <a:lnSpc>
-                <a:spcPct val="115000"/>
-              </a:lnSpc>
-              <a:spcAft>
-                <a:spcPts val="0"/>
-              </a:spcAft>
-            </a:pPr>
-            <a:r>
-              <a:rPr sz="1050" b="0" i="0">
-                <a:solidFill>
-                  <a:srgbClr val="2D2D2D"/>
-                </a:solidFill>
-                <a:latin typeface="Arial"/>
-              </a:rPr>
-              <a:t>under Zero-Layoff</a:t>
+              <a:t>converted, not cut</a:t>
             </a:r>
           </a:p>
         </p:txBody>
@@ -17301,7 +17273,7 @@
                 </a:solidFill>
                 <a:latin typeface="Arial"/>
               </a:rPr>
-              <a:t>annual run-rate value</a:t>
+              <a:t>in yearly value against a</a:t>
             </a:r>
           </a:p>
           <a:p>
@@ -17320,7 +17292,7 @@
                 </a:solidFill>
                 <a:latin typeface="Arial"/>
               </a:rPr>
-              <a:t>against a ₹200 Cr</a:t>
+              <a:t>₹200 Cr one-off spend.</a:t>
             </a:r>
           </a:p>
           <a:p>
@@ -17339,26 +17311,7 @@
                 </a:solidFill>
                 <a:latin typeface="Arial"/>
               </a:rPr>
-              <a:t>one-time investment</a:t>
-            </a:r>
-          </a:p>
-          <a:p>
-            <a:pPr algn="l">
-              <a:lnSpc>
-                <a:spcPct val="115000"/>
-              </a:lnSpc>
-              <a:spcAft>
-                <a:spcPts val="0"/>
-              </a:spcAft>
-            </a:pPr>
-            <a:r>
-              <a:rPr sz="1050" b="0" i="0">
-                <a:solidFill>
-                  <a:srgbClr val="2D2D2D"/>
-                </a:solidFill>
-                <a:latin typeface="Arial"/>
-              </a:rPr>
-              <a:t>(payback &lt; 12 months)</a:t>
+              <a:t>Payback under 12 months</a:t>
             </a:r>
           </a:p>
         </p:txBody>
@@ -17532,7 +17485,7 @@
                 </a:solidFill>
                 <a:latin typeface="Arial"/>
               </a:rPr>
-              <a:t>EBITDA margin by FY26,</a:t>
+              <a:t>EBITDA margin by FY26, up</a:t>
             </a:r>
           </a:p>
           <a:p>
@@ -17551,7 +17504,7 @@
                 </a:solidFill>
                 <a:latin typeface="Arial"/>
               </a:rPr>
-              <a:t>up from 9.5% today —</a:t>
+              <a:t>from 9.5% now, riding the</a:t>
             </a:r>
           </a:p>
           <a:p>
@@ -17570,26 +17523,7 @@
                 </a:solidFill>
                 <a:latin typeface="Arial"/>
               </a:rPr>
-              <a:t>on 15% revenue</a:t>
-            </a:r>
-          </a:p>
-          <a:p>
-            <a:pPr algn="l">
-              <a:lnSpc>
-                <a:spcPct val="115000"/>
-              </a:lnSpc>
-              <a:spcAft>
-                <a:spcPts val="0"/>
-              </a:spcAft>
-            </a:pPr>
-            <a:r>
-              <a:rPr sz="1050" b="0" i="0">
-                <a:solidFill>
-                  <a:srgbClr val="2D2D2D"/>
-                </a:solidFill>
-                <a:latin typeface="Arial"/>
-              </a:rPr>
-              <a:t>growth</a:t>
+              <a:t>15% revenue growth target</a:t>
             </a:r>
           </a:p>
         </p:txBody>
@@ -17713,22 +17647,31 @@
               </a:spcAft>
             </a:pPr>
             <a:r>
-              <a:rPr sz="1100" b="1" i="0">
+              <a:rPr sz="1100" b="0" i="0">
                 <a:solidFill>
                   <a:srgbClr val="2D2D2D"/>
                 </a:solidFill>
                 <a:latin typeface="Arial"/>
               </a:rPr>
-              <a:t>The operating model is the constraint. </a:t>
-            </a:r>
-            <a:r>
-              <a:rPr sz="1100" b="0" i="0">
+              <a:t>Every function has optimised itself in isolation, and the </a:t>
+            </a:r>
+            <a:r>
+              <a:rPr sz="1100" b="1" i="0">
                 <a:solidFill>
                   <a:srgbClr val="2D2D2D"/>
                 </a:solidFill>
                 <a:latin typeface="Arial"/>
               </a:rPr>
-              <a:t>Every function optimises locally; nobody owns the handoffs between them.</a:t>
+              <a:t>handoffs between them belong to nobody</a:t>
+            </a:r>
+            <a:r>
+              <a:rPr sz="1100" b="0" i="0">
+                <a:solidFill>
+                  <a:srgbClr val="2D2D2D"/>
+                </a:solidFill>
+                <a:latin typeface="Arial"/>
+              </a:rPr>
+              <a:t> — that's the actual constraint, more than any one function's performance.</a:t>
             </a:r>
           </a:p>
           <a:p>
@@ -17741,22 +17684,13 @@
               </a:spcAft>
             </a:pPr>
             <a:r>
-              <a:rPr sz="1100" b="1" i="0">
+              <a:rPr sz="1100" b="0" i="0">
                 <a:solidFill>
                   <a:srgbClr val="2D2D2D"/>
                 </a:solidFill>
                 <a:latin typeface="Arial"/>
               </a:rPr>
-              <a:t>Routine work is under-counted. </a:t>
-            </a:r>
-            <a:r>
-              <a:rPr sz="1100" b="0" i="0">
-                <a:solidFill>
-                  <a:srgbClr val="2D2D2D"/>
-                </a:solidFill>
-                <a:latin typeface="Arial"/>
-              </a:rPr>
-              <a:t>The two largest functions are the most routine-heavy, so the true load is 54%, not 48%.</a:t>
+              <a:t>The 48% routine-work figure in Exhibit 4 is a plain average across six functions. Weight it by headcount and it becomes 54%, because the two biggest functions are also the most routine-heavy.</a:t>
             </a:r>
           </a:p>
           <a:p>
@@ -17769,22 +17703,13 @@
               </a:spcAft>
             </a:pPr>
             <a:r>
-              <a:rPr sz="1100" b="1" i="0">
+              <a:rPr sz="1100" b="0" i="0">
                 <a:solidFill>
                   <a:srgbClr val="2D2D2D"/>
                 </a:solidFill>
                 <a:latin typeface="Arial"/>
               </a:rPr>
-              <a:t>The biggest prize is the least ready. </a:t>
-            </a:r>
-            <a:r>
-              <a:rPr sz="1100" b="0" i="0">
-                <a:solidFill>
-                  <a:srgbClr val="2D2D2D"/>
-                </a:solidFill>
-                <a:latin typeface="Arial"/>
-              </a:rPr>
-              <a:t>Retail Operations ranks #2 on value but scores 1.35/5 on adoption readiness (fear 4.3/5).</a:t>
+              <a:t>Retail Operations is the case's #2 priority by value, and dead last on readiness — 1.35 out of 5, fear at 4.3.</a:t>
             </a:r>
           </a:p>
         </p:txBody>
@@ -17908,22 +17833,13 @@
               </a:spcAft>
             </a:pPr>
             <a:r>
-              <a:rPr sz="1100" b="1" i="0">
+              <a:rPr sz="1100" b="0" i="0">
                 <a:solidFill>
                   <a:srgbClr val="2D2D2D"/>
                 </a:solidFill>
                 <a:latin typeface="Arial"/>
               </a:rPr>
-              <a:t>Phase 1: Marketing &amp; CX, Merchandising, Retail Ops </a:t>
-            </a:r>
-            <a:r>
-              <a:rPr sz="1100" b="0" i="0">
-                <a:solidFill>
-                  <a:srgbClr val="2D2D2D"/>
-                </a:solidFill>
-                <a:latin typeface="Arial"/>
-              </a:rPr>
-              <a:t>— but Retail enters as a 20-store readiness pilot, not a 200-store rollout.</a:t>
+              <a:t>Scale Marketing &amp; CX and Merchandising first. Retail Operations joins them, but only as a 20-store pilot — not a 200-store rollout on day one.</a:t>
             </a:r>
           </a:p>
           <a:p>
@@ -17942,7 +17858,7 @@
                 </a:solidFill>
                 <a:latin typeface="Arial"/>
               </a:rPr>
-              <a:t>Federated hub-and-spoke AI CoE </a:t>
+              <a:t>One federated CoE: </a:t>
             </a:r>
             <a:r>
               <a:rPr sz="1100" b="0" i="0">
@@ -17951,7 +17867,7 @@
                 </a:solidFill>
                 <a:latin typeface="Arial"/>
               </a:rPr>
-              <a:t>— a central platform and standards hub with embedded squads in each function.</a:t>
+              <a:t>a central hub for platform and standards, with squads embedded inside each function.</a:t>
             </a:r>
           </a:p>
           <a:p>
@@ -17964,22 +17880,13 @@
               </a:spcAft>
             </a:pPr>
             <a:r>
-              <a:rPr sz="1100" b="1" i="0">
+              <a:rPr sz="1100" b="0" i="0">
                 <a:solidFill>
                   <a:srgbClr val="2D2D2D"/>
                 </a:solidFill>
                 <a:latin typeface="Arial"/>
               </a:rPr>
-              <a:t>Brand-differentiated governance. </a:t>
-            </a:r>
-            <a:r>
-              <a:rPr sz="1100" b="0" i="0">
-                <a:solidFill>
-                  <a:srgbClr val="2D2D2D"/>
-                </a:solidFill>
-                <a:latin typeface="Arial"/>
-              </a:rPr>
-              <a:t>Maison Luxe stays human-led by design; SpeedStyle goes AI-forward. One policy would damage one of them.</a:t>
+              <a:t>Governance isn't one policy for five brands. Maison Luxe needs to stay human-led; SpeedStyle can go AI-forward. Swap those two and you damage both.</a:t>
             </a:r>
           </a:p>
         </p:txBody>
@@ -18261,7 +18168,7 @@
                 </a:solidFill>
                 <a:latin typeface="Georgia"/>
               </a:rPr>
-              <a:t>Four deliverables, one integrated answer — sequenced to build trust before scale</a:t>
+              <a:t>Four deliverables, sequenced so trust comes before scale</a:t>
             </a:r>
           </a:p>
         </p:txBody>
@@ -19033,25 +18940,7 @@
                 </a:solidFill>
                 <a:latin typeface="Arial"/>
               </a:rPr>
-              <a:t>Highest-readiness functions go first so the first visible AI story inside StyleVerse is a </a:t>
-            </a:r>
-            <a:r>
-              <a:rPr sz="1050" b="1" i="0">
-                <a:solidFill>
-                  <a:srgbClr val="2D2D2D"/>
-                </a:solidFill>
-                <a:latin typeface="Arial"/>
-              </a:rPr>
-              <a:t>success, not a threat</a:t>
-            </a:r>
-            <a:r>
-              <a:rPr sz="1050" b="0" i="0">
-                <a:solidFill>
-                  <a:srgbClr val="2D2D2D"/>
-                </a:solidFill>
-                <a:latin typeface="Arial"/>
-              </a:rPr>
-              <a:t>.</a:t>
+              <a:t>We start with the functions already comfortable with AI, so the first thing employees see is a win, not a threat.</a:t>
             </a:r>
           </a:p>
           <a:p>
@@ -19070,7 +18959,7 @@
                 </a:solidFill>
                 <a:latin typeface="Arial"/>
               </a:rPr>
-              <a:t>Manufacturing is last despite the largest headcount — fear is 4.5/5 and digital skill 1.8/5. Sequencing it early would confirm employees' worst fear and stall the whole programme.</a:t>
+              <a:t>Manufacturing has the largest headcount of any function and it still comes last. Fear there sits at 4.5 out of 5, digital skill at 1.8. Going in early would confirm exactly what people are afraid of.</a:t>
             </a:r>
           </a:p>
         </p:txBody>
@@ -19352,7 +19241,7 @@
                 </a:solidFill>
                 <a:latin typeface="Georgia"/>
               </a:rPr>
-              <a:t>Growth is not the problem. The gap between insight and action is.</a:t>
+              <a:t>Insight is taking too long to become action, and that lag is what's capping growth</a:t>
             </a:r>
           </a:p>
         </p:txBody>
@@ -20205,8 +20094,8 @@
         </p:nvSpPr>
         <p:spPr>
           <a:xfrm>
-            <a:off x="457200" y="3127248"/>
-            <a:ext cx="11274552" cy="1024128"/>
+            <a:off x="457200" y="3108960"/>
+            <a:ext cx="11274552" cy="1188720"/>
           </a:xfrm>
           <a:prstGeom prst="rect">
             <a:avLst/>
@@ -20249,8 +20138,8 @@
         </p:nvSpPr>
         <p:spPr>
           <a:xfrm>
-            <a:off x="713232" y="3310128"/>
-            <a:ext cx="10789920" cy="731520"/>
+            <a:off x="713232" y="3236976"/>
+            <a:ext cx="10789920" cy="960120"/>
           </a:xfrm>
           <a:prstGeom prst="rect">
             <a:avLst/>
@@ -20265,48 +20154,57 @@
           <a:p>
             <a:pPr algn="l">
               <a:lnSpc>
-                <a:spcPct val="120000"/>
+                <a:spcPct val="118000"/>
               </a:lnSpc>
               <a:spcAft>
-                <a:spcPts val="600"/>
+                <a:spcPts val="500"/>
               </a:spcAft>
             </a:pPr>
             <a:r>
-              <a:rPr sz="1250" b="1" i="0">
-                <a:solidFill>
-                  <a:srgbClr val="FFB600"/>
+              <a:rPr sz="1150" b="0" i="0">
+                <a:solidFill>
+                  <a:srgbClr val="FFFFFF"/>
                 </a:solidFill>
                 <a:latin typeface="Arial"/>
               </a:rPr>
-              <a:t>The common cause:  </a:t>
-            </a:r>
-            <a:r>
-              <a:rPr sz="1250" b="0" i="0">
-                <a:solidFill>
-                  <a:srgbClr val="FFFFFF"/>
+              <a:t>Each function built its own systems and processes over the years. Nobody ended up owning the </a:t>
+            </a:r>
+            <a:r>
+              <a:rPr sz="1150" b="1" i="0">
+                <a:solidFill>
+                  <a:srgbClr val="FFB600"/>
                 </a:solidFill>
                 <a:latin typeface="Arial"/>
               </a:rPr>
-              <a:t>each function has optimised its own systems and processes — so the handoffs between them are owned by nobody and bridged manually.</a:t>
+              <a:t>handoffs between them</a:t>
+            </a:r>
+            <a:r>
+              <a:rPr sz="1150" b="0" i="0">
+                <a:solidFill>
+                  <a:srgbClr val="FFFFFF"/>
+                </a:solidFill>
+                <a:latin typeface="Arial"/>
+              </a:rPr>
+              <a:t>, so people bridge the gaps by hand, every single time.</a:t>
             </a:r>
           </a:p>
           <a:p>
             <a:pPr algn="l">
               <a:lnSpc>
-                <a:spcPct val="120000"/>
+                <a:spcPct val="118000"/>
               </a:lnSpc>
               <a:spcAft>
-                <a:spcPts val="600"/>
+                <a:spcPts val="500"/>
               </a:spcAft>
             </a:pPr>
             <a:r>
-              <a:rPr sz="1150" b="0" i="0">
+              <a:rPr sz="1100" b="0" i="0">
                 <a:solidFill>
                   <a:srgbClr val="DEDAD6"/>
                 </a:solidFill>
                 <a:latin typeface="Arial"/>
               </a:rPr>
-              <a:t>AI applied function-by-function would automate the silos instead of dissolving them. The unit of redesign has to be the workflow, not the department.</a:t>
+              <a:t>Automate each function on its own and you'd just automate the silos — the fragmentation would still be there, only faster. Redesign has to happen at the level of the workflow, not the department.</a:t>
             </a:r>
           </a:p>
         </p:txBody>
@@ -20392,7 +20290,7 @@
                 </a:solidFill>
                 <a:latin typeface="Arial"/>
               </a:rPr>
-              <a:t>AND THE PRIZE IS BIGGER THAN IT LOOKS</a:t>
+              <a:t>THE PRIZE IS ALSO BIGGER THAN IT LOOKS</a:t>
             </a:r>
           </a:p>
         </p:txBody>
@@ -20434,27 +20332,127 @@
                 </a:solidFill>
                 <a:latin typeface="Arial"/>
               </a:rPr>
-              <a:t>Exhibit 4 reports an organisation average of 48% routine work. That is an </a:t>
+              <a:t>Exhibit 4's 48% is a plain average across six functions. Weight it by headcount instead — Manufacturing (11,000 people, 60% routine) and Retail (10,000, 55%) pull hardest — and it becomes </a:t>
             </a:r>
             <a:r>
               <a:rPr sz="1100" b="1" i="0">
                 <a:solidFill>
-                  <a:srgbClr val="2D2D2D"/>
+                  <a:srgbClr val="D04A02"/>
                 </a:solidFill>
                 <a:latin typeface="Arial"/>
               </a:rPr>
-              <a:t>unweighted</a:t>
-            </a:r>
-            <a:r>
-              <a:rPr sz="1100" b="0" i="0">
-                <a:solidFill>
-                  <a:srgbClr val="2D2D2D"/>
+              <a:t>54.1%.</a:t>
+            </a:r>
+          </a:p>
+        </p:txBody>
+      </p:sp>
+      <p:sp>
+        <p:nvSpPr>
+          <p:cNvPr id="26" name="Rectangle 25"/>
+          <p:cNvSpPr/>
+          <p:nvPr/>
+        </p:nvSpPr>
+        <p:spPr>
+          <a:xfrm>
+            <a:off x="6199632" y="4334256"/>
+            <a:ext cx="5532120" cy="1865376"/>
+          </a:xfrm>
+          <a:prstGeom prst="rect">
+            <a:avLst/>
+          </a:prstGeom>
+          <a:solidFill>
+            <a:srgbClr val="F4F1EF"/>
+          </a:solidFill>
+          <a:ln>
+            <a:noFill/>
+          </a:ln>
+          <a:effectLst/>
+        </p:spPr>
+        <p:style>
+          <a:lnRef idx="1">
+            <a:schemeClr val="accent1"/>
+          </a:lnRef>
+          <a:fillRef idx="3">
+            <a:schemeClr val="accent1"/>
+          </a:fillRef>
+          <a:effectRef idx="2">
+            <a:schemeClr val="accent1"/>
+          </a:effectRef>
+          <a:fontRef idx="minor">
+            <a:schemeClr val="lt1"/>
+          </a:fontRef>
+        </p:style>
+        <p:txBody>
+          <a:bodyPr rtlCol="0" anchor="ctr"/>
+          <a:lstStyle/>
+          <a:p>
+            <a:pPr algn="ctr"/>
+          </a:p>
+        </p:txBody>
+      </p:sp>
+      <p:sp>
+        <p:nvSpPr>
+          <p:cNvPr id="27" name="TextBox 26"/>
+          <p:cNvSpPr txBox="1"/>
+          <p:nvPr/>
+        </p:nvSpPr>
+        <p:spPr>
+          <a:xfrm>
+            <a:off x="6400800" y="4480560"/>
+            <a:ext cx="5120640" cy="237744"/>
+          </a:xfrm>
+          <a:prstGeom prst="rect">
+            <a:avLst/>
+          </a:prstGeom>
+          <a:noFill/>
+        </p:spPr>
+        <p:txBody>
+          <a:bodyPr wrap="square" anchor="t" lIns="0" rIns="0" tIns="0" bIns="0">
+            <a:spAutoFit/>
+          </a:bodyPr>
+          <a:lstStyle/>
+          <a:p>
+            <a:pPr algn="l">
+              <a:lnSpc>
+                <a:spcPct val="100000"/>
+              </a:lnSpc>
+              <a:spcAft>
+                <a:spcPts val="0"/>
+              </a:spcAft>
+            </a:pPr>
+            <a:r>
+              <a:rPr sz="1050" b="1" i="0">
+                <a:solidFill>
+                  <a:srgbClr val="D04A02"/>
                 </a:solidFill>
                 <a:latin typeface="Arial"/>
               </a:rPr>
-              <a:t> mean of the six functions.</a:t>
-            </a:r>
-          </a:p>
+              <a:t>WHY THAT MATTERS</a:t>
+            </a:r>
+          </a:p>
+        </p:txBody>
+      </p:sp>
+      <p:sp>
+        <p:nvSpPr>
+          <p:cNvPr id="28" name="TextBox 27"/>
+          <p:cNvSpPr txBox="1"/>
+          <p:nvPr/>
+        </p:nvSpPr>
+        <p:spPr>
+          <a:xfrm>
+            <a:off x="6400800" y="4773168"/>
+            <a:ext cx="5138928" cy="1280160"/>
+          </a:xfrm>
+          <a:prstGeom prst="rect">
+            <a:avLst/>
+          </a:prstGeom>
+          <a:noFill/>
+        </p:spPr>
+        <p:txBody>
+          <a:bodyPr wrap="square" anchor="t" lIns="0" rIns="0" tIns="0" bIns="0">
+            <a:spAutoFit/>
+          </a:bodyPr>
+          <a:lstStyle/>
           <a:p>
             <a:pPr algn="l">
               <a:lnSpc>
@@ -20465,150 +20463,13 @@
               </a:spcAft>
             </a:pPr>
             <a:r>
-              <a:rPr sz="1100" b="1" i="0">
-                <a:solidFill>
-                  <a:srgbClr val="D04A02"/>
+              <a:rPr sz="1100" b="0" i="0">
+                <a:solidFill>
+                  <a:srgbClr val="2D2D2D"/>
                 </a:solidFill>
                 <a:latin typeface="Arial"/>
               </a:rPr>
-              <a:t>Weighted by headcount it is 54.1%</a:t>
-            </a:r>
-            <a:r>
-              <a:rPr sz="1100" b="0" i="0">
-                <a:solidFill>
-                  <a:srgbClr val="2D2D2D"/>
-                </a:solidFill>
-                <a:latin typeface="Arial"/>
-              </a:rPr>
-              <a:t> — because the two largest functions (Manufacturing 11,000 at 60%; Retail 10,000 at 55%) are the most routine-heavy of all.</a:t>
-            </a:r>
-          </a:p>
-        </p:txBody>
-      </p:sp>
-      <p:sp>
-        <p:nvSpPr>
-          <p:cNvPr id="26" name="Rectangle 25"/>
-          <p:cNvSpPr/>
-          <p:nvPr/>
-        </p:nvSpPr>
-        <p:spPr>
-          <a:xfrm>
-            <a:off x="6199632" y="4334256"/>
-            <a:ext cx="5532120" cy="1865376"/>
-          </a:xfrm>
-          <a:prstGeom prst="rect">
-            <a:avLst/>
-          </a:prstGeom>
-          <a:solidFill>
-            <a:srgbClr val="F4F1EF"/>
-          </a:solidFill>
-          <a:ln>
-            <a:noFill/>
-          </a:ln>
-          <a:effectLst/>
-        </p:spPr>
-        <p:style>
-          <a:lnRef idx="1">
-            <a:schemeClr val="accent1"/>
-          </a:lnRef>
-          <a:fillRef idx="3">
-            <a:schemeClr val="accent1"/>
-          </a:fillRef>
-          <a:effectRef idx="2">
-            <a:schemeClr val="accent1"/>
-          </a:effectRef>
-          <a:fontRef idx="minor">
-            <a:schemeClr val="lt1"/>
-          </a:fontRef>
-        </p:style>
-        <p:txBody>
-          <a:bodyPr rtlCol="0" anchor="ctr"/>
-          <a:lstStyle/>
-          <a:p>
-            <a:pPr algn="ctr"/>
-          </a:p>
-        </p:txBody>
-      </p:sp>
-      <p:sp>
-        <p:nvSpPr>
-          <p:cNvPr id="27" name="TextBox 26"/>
-          <p:cNvSpPr txBox="1"/>
-          <p:nvPr/>
-        </p:nvSpPr>
-        <p:spPr>
-          <a:xfrm>
-            <a:off x="6400800" y="4480560"/>
-            <a:ext cx="5120640" cy="237744"/>
-          </a:xfrm>
-          <a:prstGeom prst="rect">
-            <a:avLst/>
-          </a:prstGeom>
-          <a:noFill/>
-        </p:spPr>
-        <p:txBody>
-          <a:bodyPr wrap="square" anchor="t" lIns="0" rIns="0" tIns="0" bIns="0">
-            <a:spAutoFit/>
-          </a:bodyPr>
-          <a:lstStyle/>
-          <a:p>
-            <a:pPr algn="l">
-              <a:lnSpc>
-                <a:spcPct val="100000"/>
-              </a:lnSpc>
-              <a:spcAft>
-                <a:spcPts val="0"/>
-              </a:spcAft>
-            </a:pPr>
-            <a:r>
-              <a:rPr sz="1050" b="1" i="0">
-                <a:solidFill>
-                  <a:srgbClr val="D04A02"/>
-                </a:solidFill>
-                <a:latin typeface="Arial"/>
-              </a:rPr>
-              <a:t>WHY THAT MATTERS</a:t>
-            </a:r>
-          </a:p>
-        </p:txBody>
-      </p:sp>
-      <p:sp>
-        <p:nvSpPr>
-          <p:cNvPr id="28" name="TextBox 27"/>
-          <p:cNvSpPr txBox="1"/>
-          <p:nvPr/>
-        </p:nvSpPr>
-        <p:spPr>
-          <a:xfrm>
-            <a:off x="6400800" y="4773168"/>
-            <a:ext cx="5138928" cy="1280160"/>
-          </a:xfrm>
-          <a:prstGeom prst="rect">
-            <a:avLst/>
-          </a:prstGeom>
-          <a:noFill/>
-        </p:spPr>
-        <p:txBody>
-          <a:bodyPr wrap="square" anchor="t" lIns="0" rIns="0" tIns="0" bIns="0">
-            <a:spAutoFit/>
-          </a:bodyPr>
-          <a:lstStyle/>
-          <a:p>
-            <a:pPr algn="l">
-              <a:lnSpc>
-                <a:spcPct val="120000"/>
-              </a:lnSpc>
-              <a:spcAft>
-                <a:spcPts val="700"/>
-              </a:spcAft>
-            </a:pPr>
-            <a:r>
-              <a:rPr sz="1100" b="0" i="0">
-                <a:solidFill>
-                  <a:srgbClr val="2D2D2D"/>
-                </a:solidFill>
-                <a:latin typeface="Arial"/>
-              </a:rPr>
-              <a:t>A 5.7-point understatement is roughly </a:t>
+              <a:t>That 5.7-point gap works out to roughly </a:t>
             </a:r>
             <a:r>
               <a:rPr sz="1100" b="1" i="0">
@@ -20626,26 +20487,7 @@
                 </a:solidFill>
                 <a:latin typeface="Arial"/>
               </a:rPr>
-              <a:t> of routine work missing from the plan — larger than the entire Corporate function.</a:t>
-            </a:r>
-          </a:p>
-          <a:p>
-            <a:pPr algn="l">
-              <a:lnSpc>
-                <a:spcPct val="120000"/>
-              </a:lnSpc>
-              <a:spcAft>
-                <a:spcPts val="700"/>
-              </a:spcAft>
-            </a:pPr>
-            <a:r>
-              <a:rPr sz="1100" b="0" i="0">
-                <a:solidFill>
-                  <a:srgbClr val="2D2D2D"/>
-                </a:solidFill>
-                <a:latin typeface="Arial"/>
-              </a:rPr>
-              <a:t>Sizing the programme off the headline average would under-scope the platform, the reskilling budget and the redeployment pipeline.</a:t>
+              <a:t> of routine work — more people than the entire Corporate function — that a plan built on the headline number simply misses. The platform, the reskilling budget, the redeployment pipeline: all of it ends up sized too small.</a:t>
             </a:r>
           </a:p>
         </p:txBody>
@@ -20927,7 +20769,7 @@
                 </a:solidFill>
                 <a:latin typeface="Georgia"/>
               </a:rPr>
-              <a:t>Every activity passes the same three gates — so the classification is defensible, not arbitrary</a:t>
+              <a:t>We ran every activity through the same three gates, so the calls hold up to scrutiny</a:t>
             </a:r>
           </a:p>
         </p:txBody>
@@ -22186,7 +22028,7 @@
                 </a:solidFill>
                 <a:latin typeface="Arial"/>
               </a:rPr>
-              <a:t>WHERE WE CHALLENGE EXHIBIT 4 — as the case invites</a:t>
+              <a:t>WHERE WE PUSHED BACK ON EXHIBIT 4 (as the case invites us to)</a:t>
             </a:r>
           </a:p>
         </p:txBody>
@@ -22228,7 +22070,7 @@
                 </a:solidFill>
                 <a:latin typeface="Arial"/>
               </a:rPr>
-              <a:t>Retail Operations — the human share is a design choice, not a constant. </a:t>
+              <a:t>Retail Operations: </a:t>
             </a:r>
             <a:r>
               <a:rPr sz="1100" b="0" i="0">
@@ -22237,7 +22079,7 @@
                 </a:solidFill>
                 <a:latin typeface="Arial"/>
               </a:rPr>
-              <a:t>Exhibit 4 shows 20% creative/strategic. Once AI removes stock look-ups and admin, we deliberately redesign the role upward to ~35% relationship work.</a:t>
+              <a:t>the 20% creative/strategic share in Exhibit 4 isn't fixed. Once AI takes stock look-ups and admin off associates' plates, we push that figure up to roughly 35% relationship work, deliberately, as a design choice.</a:t>
             </a:r>
           </a:p>
         </p:txBody>
@@ -22279,7 +22121,7 @@
                 </a:solidFill>
                 <a:latin typeface="Arial"/>
               </a:rPr>
-              <a:t>Manufacturing — routine ≠ automatable. </a:t>
+              <a:t>Manufacturing </a:t>
             </a:r>
             <a:r>
               <a:rPr sz="1100" b="0" i="0">
@@ -22288,7 +22130,7 @@
                 </a:solidFill>
                 <a:latin typeface="Arial"/>
               </a:rPr>
-              <a:t>60% of its work is routine, but quality inspection carries safety and regulatory consequence (Gate 2). Most of it is Augmentable — AI-assisted vision with human sign-off — not Automatable.</a:t>
+              <a:t>is where routine and automatable pull apart. 60% of the work is routine, but quality inspection carries real safety and regulatory stakes (Gate 2). Most of it lands Augmentable — AI-assisted vision, human sign-off — rather than fully automated.</a:t>
             </a:r>
           </a:p>
         </p:txBody>
@@ -22570,7 +22412,7 @@
                 </a:solidFill>
                 <a:latin typeface="Georgia"/>
               </a:rPr>
-              <a:t>AI touches 82% of the work and replaces 0% of the people</a:t>
+              <a:t>How the 22/60/18 split plays out across six functions</a:t>
             </a:r>
           </a:p>
         </p:txBody>
@@ -23150,7 +22992,7 @@
                 </a:solidFill>
                 <a:latin typeface="Arial"/>
               </a:rPr>
-              <a:t>Only the 22% is executed by AI alone. The 60% is where humans get faster and better — and it is the largest prize.</a:t>
+              <a:t>Only that 22% runs on AI by itself. The 60% Augmentable slice is where people get faster and better at their jobs, and it's the biggest prize of the three by far.</a:t>
             </a:r>
           </a:p>
         </p:txBody>
@@ -23296,40 +23138,49 @@
               </a:spcAft>
             </a:pPr>
             <a:r>
-              <a:rPr sz="1200" b="1" i="0">
-                <a:solidFill>
-                  <a:srgbClr val="FFFFFF"/>
+              <a:rPr sz="1100" b="0" i="0">
+                <a:solidFill>
+                  <a:srgbClr val="DEDAD6"/>
                 </a:solidFill>
                 <a:latin typeface="Arial"/>
               </a:rPr>
-              <a:t>15,140 </a:t>
-            </a:r>
-            <a:r>
-              <a:rPr sz="1100" b="0" i="0">
-                <a:solidFill>
-                  <a:srgbClr val="DEDAD6"/>
+              <a:t>Routine work adds up to </a:t>
+            </a:r>
+            <a:r>
+              <a:rPr sz="1200" b="1" i="0">
+                <a:solidFill>
+                  <a:srgbClr val="FFFFFF"/>
                 </a:solidFill>
                 <a:latin typeface="Arial"/>
               </a:rPr>
-              <a:t>FTE-equivalents of routine work exist today. Automating 40% of it releases </a:t>
-            </a:r>
-            <a:r>
-              <a:rPr sz="1200" b="1" i="0">
-                <a:solidFill>
-                  <a:srgbClr val="FFB600"/>
+              <a:t>15,140</a:t>
+            </a:r>
+            <a:r>
+              <a:rPr sz="1100" b="0" i="0">
+                <a:solidFill>
+                  <a:srgbClr val="DEDAD6"/>
                 </a:solidFill>
                 <a:latin typeface="Arial"/>
               </a:rPr>
-              <a:t>6,056 FTE-equivalents</a:t>
-            </a:r>
-            <a:r>
-              <a:rPr sz="1100" b="0" i="0">
-                <a:solidFill>
-                  <a:srgbClr val="DEDAD6"/>
+              <a:t> FTE-equivalents today. Automate 40% of that and </a:t>
+            </a:r>
+            <a:r>
+              <a:rPr sz="1200" b="1" i="0">
+                <a:solidFill>
+                  <a:srgbClr val="FFB600"/>
                 </a:solidFill>
                 <a:latin typeface="Arial"/>
               </a:rPr>
-              <a:t> — 21.6% of the workforce.</a:t>
+              <a:t>6,056</a:t>
+            </a:r>
+            <a:r>
+              <a:rPr sz="1100" b="0" i="0">
+                <a:solidFill>
+                  <a:srgbClr val="DEDAD6"/>
+                </a:solidFill>
+                <a:latin typeface="Arial"/>
+              </a:rPr>
+              <a:t> come free — 21.6% of the whole workforce.</a:t>
             </a:r>
           </a:p>
           <a:p>
@@ -23348,7 +23199,7 @@
                 </a:solidFill>
                 <a:latin typeface="Arial"/>
               </a:rPr>
-              <a:t>Under Zero-Layoff this is capacity </a:t>
+              <a:t>None of that is a headcount cut. Zero-Layoff means the ₹200 Cr buys the </a:t>
             </a:r>
             <a:r>
               <a:rPr sz="1100" b="1" i="0">
@@ -23357,7 +23208,7 @@
                 </a:solidFill>
                 <a:latin typeface="Arial"/>
               </a:rPr>
-              <a:t>converted, not cost cut</a:t>
+              <a:t>same payroll doing better work</a:t>
             </a:r>
             <a:r>
               <a:rPr sz="1100" b="0" i="0">
@@ -23366,7 +23217,7 @@
                 </a:solidFill>
                 <a:latin typeface="Arial"/>
               </a:rPr>
-              <a:t>. The ₹200 Cr does not buy a smaller payroll — it buys the same payroll doing higher-value work.</a:t>
+              <a:t>, not a smaller payroll.</a:t>
             </a:r>
           </a:p>
         </p:txBody>
@@ -23648,7 +23499,7 @@
                 </a:solidFill>
                 <a:latin typeface="Georgia"/>
               </a:rPr>
-              <a:t>The highest-value function is the least ready — so value alone cannot set the sequence</a:t>
+              <a:t>Value alone can't set the sequence, because the highest-value function is also the least ready</a:t>
             </a:r>
           </a:p>
         </p:txBody>
@@ -24550,22 +24401,13 @@
               </a:spcAft>
             </a:pPr>
             <a:r>
-              <a:rPr sz="1100" b="1" i="0">
+              <a:rPr sz="1100" b="0" i="0">
                 <a:solidFill>
                   <a:srgbClr val="2D2D2D"/>
                 </a:solidFill>
                 <a:latin typeface="Arial"/>
               </a:rPr>
-              <a:t>Our model independently reproduces leadership's own ranking</a:t>
-            </a:r>
-            <a:r>
-              <a:rPr sz="1100" b="0" i="0">
-                <a:solidFill>
-                  <a:srgbClr val="2D2D2D"/>
-                </a:solidFill>
-                <a:latin typeface="Arial"/>
-              </a:rPr>
-              <a:t> — the two “Very High” functions score #1 and #2, and “High” scores #3. The model does not overturn management judgment; it explains and sizes it.</a:t>
+              <a:t>Run the numbers independently and you land back on leadership's own ranking: both “Very High” functions come out #1 and #2, “High” comes out #3. The model isn't here to overrule that instinct — it's here to show why it's right, and by how much.</a:t>
             </a:r>
           </a:p>
         </p:txBody>
@@ -24689,22 +24531,13 @@
               </a:spcAft>
             </a:pPr>
             <a:r>
-              <a:rPr sz="1100" b="1" i="0">
+              <a:rPr sz="1100" b="0" i="0">
                 <a:solidFill>
                   <a:srgbClr val="2D2D2D"/>
                 </a:solidFill>
                 <a:latin typeface="Arial"/>
               </a:rPr>
-              <a:t>Retail Operations: </a:t>
-            </a:r>
-            <a:r>
-              <a:rPr sz="1100" b="0" i="0">
-                <a:solidFill>
-                  <a:srgbClr val="2D2D2D"/>
-                </a:solidFill>
-                <a:latin typeface="Arial"/>
-              </a:rPr>
-              <a:t>10,000 people, 200 stores, #2 on value — and 1.35/5 on readiness, with fear at 4.3/5 and digital skill at 2.2/5. Deploying at scale here first would fail.</a:t>
+              <a:t>Retail Operations has 10,000 people across 200 stores and ranks #2 on value. Its readiness score is 1.35 out of 5, fear sits at 4.3. Rolling this out at full scale first isn't ambitious — it's a way to guarantee the programme's first headline is a failed pilot.</a:t>
             </a:r>
           </a:p>
         </p:txBody>
@@ -26155,22 +25988,31 @@
               </a:spcAft>
             </a:pPr>
             <a:r>
-              <a:rPr sz="1150" b="1" i="0">
-                <a:solidFill>
-                  <a:srgbClr val="FFB600"/>
+              <a:rPr sz="1150" b="0" i="0">
+                <a:solidFill>
+                  <a:srgbClr val="FFFFFF"/>
                 </a:solidFill>
                 <a:latin typeface="Arial"/>
               </a:rPr>
-              <a:t>Deferred deliberately:  </a:t>
-            </a:r>
-            <a:r>
-              <a:rPr sz="1150" b="0" i="0">
-                <a:solidFill>
-                  <a:srgbClr val="FFFFFF"/>
+              <a:t>Manufacturing &amp; Quality has the largest routine load of any function and the lowest readiness score on the list. </a:t>
+            </a:r>
+            <a:r>
+              <a:rPr sz="1150" b="1" i="0">
+                <a:solidFill>
+                  <a:srgbClr val="FFB600"/>
                 </a:solidFill>
                 <a:latin typeface="Arial"/>
               </a:rPr>
-              <a:t>Manufacturing &amp; Quality (11,000 people) carries the largest routine load but the lowest readiness — it is Phase 3, paired with EPR traceability where AI creates new compliance roles rather than displacing existing ones.</a:t>
+              <a:t>That's exactly why it waits for Phase 3, </a:t>
+            </a:r>
+            <a:r>
+              <a:rPr sz="1150" b="0" i="0">
+                <a:solidFill>
+                  <a:srgbClr val="FFFFFF"/>
+                </a:solidFill>
+                <a:latin typeface="Arial"/>
+              </a:rPr>
+              <a:t>paired with EPR traceability work — where AI adds new compliance roles instead of touching the inspection jobs people already have.</a:t>
             </a:r>
           </a:p>
         </p:txBody>
@@ -26452,7 +26294,7 @@
                 </a:solidFill>
                 <a:latin typeface="Georgia"/>
               </a:rPr>
-              <a:t>The workflow, not the org chart, is the unit of redesign</a:t>
+              <a:t>We're redesigning around the workflow. The org chart can mostly stay put.</a:t>
             </a:r>
           </a:p>
         </p:txBody>
@@ -27706,7 +27548,7 @@
                 </a:solidFill>
                 <a:latin typeface="Arial"/>
               </a:rPr>
-              <a:t>THE ONE STRUCTURAL RULE</a:t>
+              <a:t>THE ONE STRUCTURAL RULE WE DON'T BREAK</a:t>
             </a:r>
           </a:p>
         </p:txBody>
@@ -27742,22 +27584,13 @@
               </a:spcAft>
             </a:pPr>
             <a:r>
-              <a:rPr sz="1150" b="1" i="0">
+              <a:rPr sz="1150" b="0" i="0">
                 <a:solidFill>
                   <a:srgbClr val="2D2D2D"/>
                 </a:solidFill>
                 <a:latin typeface="Arial"/>
               </a:rPr>
-              <a:t>No AI system is deployed into a workflow that still requires a manual handoff to complete. </a:t>
-            </a:r>
-            <a:r>
-              <a:rPr sz="1150" b="0" i="0">
-                <a:solidFill>
-                  <a:srgbClr val="2D2D2D"/>
-                </a:solidFill>
-                <a:latin typeface="Arial"/>
-              </a:rPr>
-              <a:t>Automating either side of a broken handoff makes the handoff the bottleneck and delivers none of the cycle-time gain — this is precisely how StyleVerse's current fragmentation was created.</a:t>
+              <a:t>We don't deploy AI into a workflow that still needs a manual handoff to finish. Automate one side of a broken handoff and the handoff itself just becomes the new bottleneck — none of the cycle-time gain shows up. This is, more or less, exactly how StyleVerse ended up fragmented in the first place.</a:t>
             </a:r>
           </a:p>
         </p:txBody>

</xml_diff>